<commit_message>
add new SQL reports and dashboards
add new SQL reports and dashboards
</commit_message>
<xml_diff>
--- a/presentation/Flight Data Analysis.pptx
+++ b/presentation/Flight Data Analysis.pptx
@@ -6,26 +6,29 @@
   </p:sldMasterIdLst>
   <p:sldIdLst>
     <p:sldId id="257" r:id="rId2"/>
-    <p:sldId id="278" r:id="rId3"/>
+    <p:sldId id="258" r:id="rId3"/>
     <p:sldId id="259" r:id="rId4"/>
-    <p:sldId id="260" r:id="rId5"/>
+    <p:sldId id="278" r:id="rId5"/>
     <p:sldId id="279" r:id="rId6"/>
-    <p:sldId id="262" r:id="rId7"/>
-    <p:sldId id="263" r:id="rId8"/>
-    <p:sldId id="264" r:id="rId9"/>
-    <p:sldId id="265" r:id="rId10"/>
-    <p:sldId id="266" r:id="rId11"/>
-    <p:sldId id="267" r:id="rId12"/>
-    <p:sldId id="268" r:id="rId13"/>
-    <p:sldId id="269" r:id="rId14"/>
-    <p:sldId id="270" r:id="rId15"/>
-    <p:sldId id="271" r:id="rId16"/>
-    <p:sldId id="272" r:id="rId17"/>
-    <p:sldId id="273" r:id="rId18"/>
-    <p:sldId id="274" r:id="rId19"/>
-    <p:sldId id="275" r:id="rId20"/>
-    <p:sldId id="276" r:id="rId21"/>
-    <p:sldId id="277" r:id="rId22"/>
+    <p:sldId id="260" r:id="rId7"/>
+    <p:sldId id="261" r:id="rId8"/>
+    <p:sldId id="262" r:id="rId9"/>
+    <p:sldId id="263" r:id="rId10"/>
+    <p:sldId id="264" r:id="rId11"/>
+    <p:sldId id="265" r:id="rId12"/>
+    <p:sldId id="266" r:id="rId13"/>
+    <p:sldId id="267" r:id="rId14"/>
+    <p:sldId id="268" r:id="rId15"/>
+    <p:sldId id="269" r:id="rId16"/>
+    <p:sldId id="280" r:id="rId17"/>
+    <p:sldId id="270" r:id="rId18"/>
+    <p:sldId id="271" r:id="rId19"/>
+    <p:sldId id="272" r:id="rId20"/>
+    <p:sldId id="273" r:id="rId21"/>
+    <p:sldId id="274" r:id="rId22"/>
+    <p:sldId id="275" r:id="rId23"/>
+    <p:sldId id="276" r:id="rId24"/>
+    <p:sldId id="277" r:id="rId25"/>
   </p:sldIdLst>
   <p:sldSz cx="12192000" cy="6858000"/>
   <p:notesSz cx="6858000" cy="9144000"/>
@@ -279,7 +282,7 @@
           <a:p>
             <a:fld id="{EED1C14C-A143-42F5-B247-D0E800131009}" type="datetimeFigureOut">
               <a:rPr lang="en-US" smtClean="0"/>
-              <a:t>8/14/26</a:t>
+              <a:t>8/28/26</a:t>
             </a:fld>
             <a:endParaRPr lang="en-US"/>
           </a:p>
@@ -477,7 +480,7 @@
           <a:p>
             <a:fld id="{EED1C14C-A143-42F5-B247-D0E800131009}" type="datetimeFigureOut">
               <a:rPr lang="en-US" smtClean="0"/>
-              <a:t>8/14/26</a:t>
+              <a:t>8/28/26</a:t>
             </a:fld>
             <a:endParaRPr lang="en-US"/>
           </a:p>
@@ -685,7 +688,7 @@
           <a:p>
             <a:fld id="{EED1C14C-A143-42F5-B247-D0E800131009}" type="datetimeFigureOut">
               <a:rPr lang="en-US" smtClean="0"/>
-              <a:t>8/14/26</a:t>
+              <a:t>8/28/26</a:t>
             </a:fld>
             <a:endParaRPr lang="en-US"/>
           </a:p>
@@ -883,7 +886,7 @@
           <a:p>
             <a:fld id="{EED1C14C-A143-42F5-B247-D0E800131009}" type="datetimeFigureOut">
               <a:rPr lang="en-US" smtClean="0"/>
-              <a:t>8/14/26</a:t>
+              <a:t>8/28/26</a:t>
             </a:fld>
             <a:endParaRPr lang="en-US"/>
           </a:p>
@@ -1158,7 +1161,7 @@
           <a:p>
             <a:fld id="{EED1C14C-A143-42F5-B247-D0E800131009}" type="datetimeFigureOut">
               <a:rPr lang="en-US" smtClean="0"/>
-              <a:t>8/14/26</a:t>
+              <a:t>8/28/26</a:t>
             </a:fld>
             <a:endParaRPr lang="en-US"/>
           </a:p>
@@ -1423,7 +1426,7 @@
           <a:p>
             <a:fld id="{EED1C14C-A143-42F5-B247-D0E800131009}" type="datetimeFigureOut">
               <a:rPr lang="en-US" smtClean="0"/>
-              <a:t>8/14/26</a:t>
+              <a:t>8/28/26</a:t>
             </a:fld>
             <a:endParaRPr lang="en-US"/>
           </a:p>
@@ -1835,7 +1838,7 @@
           <a:p>
             <a:fld id="{EED1C14C-A143-42F5-B247-D0E800131009}" type="datetimeFigureOut">
               <a:rPr lang="en-US" smtClean="0"/>
-              <a:t>8/14/26</a:t>
+              <a:t>8/28/26</a:t>
             </a:fld>
             <a:endParaRPr lang="en-US"/>
           </a:p>
@@ -1976,7 +1979,7 @@
           <a:p>
             <a:fld id="{EED1C14C-A143-42F5-B247-D0E800131009}" type="datetimeFigureOut">
               <a:rPr lang="en-US" smtClean="0"/>
-              <a:t>8/14/26</a:t>
+              <a:t>8/28/26</a:t>
             </a:fld>
             <a:endParaRPr lang="en-US"/>
           </a:p>
@@ -2089,7 +2092,7 @@
           <a:p>
             <a:fld id="{EED1C14C-A143-42F5-B247-D0E800131009}" type="datetimeFigureOut">
               <a:rPr lang="en-US" smtClean="0"/>
-              <a:t>8/14/26</a:t>
+              <a:t>8/28/26</a:t>
             </a:fld>
             <a:endParaRPr lang="en-US"/>
           </a:p>
@@ -2400,7 +2403,7 @@
           <a:p>
             <a:fld id="{EED1C14C-A143-42F5-B247-D0E800131009}" type="datetimeFigureOut">
               <a:rPr lang="en-US" smtClean="0"/>
-              <a:t>8/14/26</a:t>
+              <a:t>8/28/26</a:t>
             </a:fld>
             <a:endParaRPr lang="en-US"/>
           </a:p>
@@ -2688,7 +2691,7 @@
           <a:p>
             <a:fld id="{EED1C14C-A143-42F5-B247-D0E800131009}" type="datetimeFigureOut">
               <a:rPr lang="en-US" smtClean="0"/>
-              <a:t>8/14/26</a:t>
+              <a:t>8/28/26</a:t>
             </a:fld>
             <a:endParaRPr lang="en-US"/>
           </a:p>
@@ -2929,7 +2932,7 @@
           <a:p>
             <a:fld id="{EED1C14C-A143-42F5-B247-D0E800131009}" type="datetimeFigureOut">
               <a:rPr lang="en-US" smtClean="0"/>
-              <a:t>8/14/26</a:t>
+              <a:t>8/28/26</a:t>
             </a:fld>
             <a:endParaRPr lang="en-US"/>
           </a:p>
@@ -3351,7 +3354,7 @@
           <p:cNvPr id="2" name="slide2" descr="Dashboard 1">
             <a:extLst>
               <a:ext uri="{FF2B5EF4-FFF2-40B4-BE49-F238E27FC236}">
-                <a16:creationId xmlns:a16="http://schemas.microsoft.com/office/drawing/2014/main" id="{B2E63A86-DB2E-4197-94BC-298FAE7F01FE}"/>
+                <a16:creationId xmlns:a16="http://schemas.microsoft.com/office/drawing/2014/main" id="{9E4050B5-FF32-49CD-97F0-6F2B79EA4B7F}"/>
               </a:ext>
             </a:extLst>
           </p:cNvPr>
@@ -3374,8 +3377,8 @@
         </p:blipFill>
         <p:spPr>
           <a:xfrm>
-            <a:off x="880355" y="0"/>
-            <a:ext cx="10431289" cy="6858000"/>
+            <a:off x="986450" y="0"/>
+            <a:ext cx="10219099" cy="6858000"/>
           </a:xfrm>
           <a:prstGeom prst="rect">
             <a:avLst/>
@@ -3414,10 +3417,10 @@
       </p:grpSpPr>
       <p:pic>
         <p:nvPicPr>
-          <p:cNvPr id="11" name="slide11" descr="Dashboard 10">
-            <a:extLst>
-              <a:ext uri="{FF2B5EF4-FFF2-40B4-BE49-F238E27FC236}">
-                <a16:creationId xmlns:a16="http://schemas.microsoft.com/office/drawing/2014/main" id="{9FFB9B6D-4062-4EDB-B322-65CD8E6CAA97}"/>
+          <p:cNvPr id="9" name="slide9" descr="Dashboard 8">
+            <a:extLst>
+              <a:ext uri="{FF2B5EF4-FFF2-40B4-BE49-F238E27FC236}">
+                <a16:creationId xmlns:a16="http://schemas.microsoft.com/office/drawing/2014/main" id="{7775A76C-EF6F-4933-A586-D7216D431DED}"/>
               </a:ext>
             </a:extLst>
           </p:cNvPr>
@@ -3440,8 +3443,8 @@
         </p:blipFill>
         <p:spPr>
           <a:xfrm>
-            <a:off x="880355" y="0"/>
-            <a:ext cx="10431289" cy="6858000"/>
+            <a:off x="986450" y="0"/>
+            <a:ext cx="10219099" cy="6858000"/>
           </a:xfrm>
           <a:prstGeom prst="rect">
             <a:avLst/>
@@ -3480,10 +3483,10 @@
       </p:grpSpPr>
       <p:pic>
         <p:nvPicPr>
-          <p:cNvPr id="12" name="slide12" descr="Dashboard 11">
-            <a:extLst>
-              <a:ext uri="{FF2B5EF4-FFF2-40B4-BE49-F238E27FC236}">
-                <a16:creationId xmlns:a16="http://schemas.microsoft.com/office/drawing/2014/main" id="{4D85FF88-4445-4229-8122-3111D61444E9}"/>
+          <p:cNvPr id="10" name="slide10" descr="Dashboard 9">
+            <a:extLst>
+              <a:ext uri="{FF2B5EF4-FFF2-40B4-BE49-F238E27FC236}">
+                <a16:creationId xmlns:a16="http://schemas.microsoft.com/office/drawing/2014/main" id="{57F7D365-D4B5-41FB-AF35-19CED9993DE2}"/>
               </a:ext>
             </a:extLst>
           </p:cNvPr>
@@ -3506,8 +3509,8 @@
         </p:blipFill>
         <p:spPr>
           <a:xfrm>
-            <a:off x="880355" y="0"/>
-            <a:ext cx="10431289" cy="6858000"/>
+            <a:off x="986450" y="0"/>
+            <a:ext cx="10219099" cy="6858000"/>
           </a:xfrm>
           <a:prstGeom prst="rect">
             <a:avLst/>
@@ -3546,10 +3549,10 @@
       </p:grpSpPr>
       <p:pic>
         <p:nvPicPr>
-          <p:cNvPr id="13" name="slide13" descr="Dashboard 12">
-            <a:extLst>
-              <a:ext uri="{FF2B5EF4-FFF2-40B4-BE49-F238E27FC236}">
-                <a16:creationId xmlns:a16="http://schemas.microsoft.com/office/drawing/2014/main" id="{856171DA-F6D7-41F4-A1EE-38835AFFC6A3}"/>
+          <p:cNvPr id="11" name="slide11" descr="Dashboard 10">
+            <a:extLst>
+              <a:ext uri="{FF2B5EF4-FFF2-40B4-BE49-F238E27FC236}">
+                <a16:creationId xmlns:a16="http://schemas.microsoft.com/office/drawing/2014/main" id="{3F599556-9E51-4241-B3BF-50F389BD116B}"/>
               </a:ext>
             </a:extLst>
           </p:cNvPr>
@@ -3572,8 +3575,8 @@
         </p:blipFill>
         <p:spPr>
           <a:xfrm>
-            <a:off x="880355" y="0"/>
-            <a:ext cx="10431289" cy="6858000"/>
+            <a:off x="986450" y="0"/>
+            <a:ext cx="10219099" cy="6858000"/>
           </a:xfrm>
           <a:prstGeom prst="rect">
             <a:avLst/>
@@ -3612,10 +3615,10 @@
       </p:grpSpPr>
       <p:pic>
         <p:nvPicPr>
-          <p:cNvPr id="14" name="slide14" descr="Dashboard 13">
-            <a:extLst>
-              <a:ext uri="{FF2B5EF4-FFF2-40B4-BE49-F238E27FC236}">
-                <a16:creationId xmlns:a16="http://schemas.microsoft.com/office/drawing/2014/main" id="{4EF8B5A9-4FE0-4772-822A-DFE787E6F273}"/>
+          <p:cNvPr id="12" name="slide12" descr="Dashboard 11">
+            <a:extLst>
+              <a:ext uri="{FF2B5EF4-FFF2-40B4-BE49-F238E27FC236}">
+                <a16:creationId xmlns:a16="http://schemas.microsoft.com/office/drawing/2014/main" id="{690C5DD8-9CEA-4D6A-B5A1-FB143CDCF36D}"/>
               </a:ext>
             </a:extLst>
           </p:cNvPr>
@@ -3638,8 +3641,8 @@
         </p:blipFill>
         <p:spPr>
           <a:xfrm>
-            <a:off x="880355" y="0"/>
-            <a:ext cx="10431289" cy="6858000"/>
+            <a:off x="986450" y="0"/>
+            <a:ext cx="10219099" cy="6858000"/>
           </a:xfrm>
           <a:prstGeom prst="rect">
             <a:avLst/>
@@ -3678,10 +3681,10 @@
       </p:grpSpPr>
       <p:pic>
         <p:nvPicPr>
-          <p:cNvPr id="15" name="slide15" descr="Dashboard 14">
-            <a:extLst>
-              <a:ext uri="{FF2B5EF4-FFF2-40B4-BE49-F238E27FC236}">
-                <a16:creationId xmlns:a16="http://schemas.microsoft.com/office/drawing/2014/main" id="{524EA27C-B97B-4FD2-9492-4B2827B94E63}"/>
+          <p:cNvPr id="13" name="slide13" descr="Dashboard 12">
+            <a:extLst>
+              <a:ext uri="{FF2B5EF4-FFF2-40B4-BE49-F238E27FC236}">
+                <a16:creationId xmlns:a16="http://schemas.microsoft.com/office/drawing/2014/main" id="{5EB1E22D-4873-4D8D-82A3-BAE7318C932B}"/>
               </a:ext>
             </a:extLst>
           </p:cNvPr>
@@ -3704,8 +3707,8 @@
         </p:blipFill>
         <p:spPr>
           <a:xfrm>
-            <a:off x="880355" y="0"/>
-            <a:ext cx="10431289" cy="6858000"/>
+            <a:off x="986450" y="0"/>
+            <a:ext cx="10219099" cy="6858000"/>
           </a:xfrm>
           <a:prstGeom prst="rect">
             <a:avLst/>
@@ -3744,10 +3747,10 @@
       </p:grpSpPr>
       <p:pic>
         <p:nvPicPr>
-          <p:cNvPr id="16" name="slide16" descr="Dashboard 15">
-            <a:extLst>
-              <a:ext uri="{FF2B5EF4-FFF2-40B4-BE49-F238E27FC236}">
-                <a16:creationId xmlns:a16="http://schemas.microsoft.com/office/drawing/2014/main" id="{7BCB74F2-0360-4AAA-A27F-638AAADE4CDD}"/>
+          <p:cNvPr id="14" name="slide14" descr="Dashboard 13">
+            <a:extLst>
+              <a:ext uri="{FF2B5EF4-FFF2-40B4-BE49-F238E27FC236}">
+                <a16:creationId xmlns:a16="http://schemas.microsoft.com/office/drawing/2014/main" id="{C13B6C40-0D83-4055-B8E3-146DEA75ADE7}"/>
               </a:ext>
             </a:extLst>
           </p:cNvPr>
@@ -3770,8 +3773,8 @@
         </p:blipFill>
         <p:spPr>
           <a:xfrm>
-            <a:off x="880355" y="0"/>
-            <a:ext cx="10431289" cy="6858000"/>
+            <a:off x="986450" y="0"/>
+            <a:ext cx="10219099" cy="6858000"/>
           </a:xfrm>
           <a:prstGeom prst="rect">
             <a:avLst/>
@@ -3810,10 +3813,10 @@
       </p:grpSpPr>
       <p:pic>
         <p:nvPicPr>
-          <p:cNvPr id="17" name="slide17" descr="Dashboard 16">
-            <a:extLst>
-              <a:ext uri="{FF2B5EF4-FFF2-40B4-BE49-F238E27FC236}">
-                <a16:creationId xmlns:a16="http://schemas.microsoft.com/office/drawing/2014/main" id="{5A62B196-0F78-412D-AD8A-669BE149F6B1}"/>
+          <p:cNvPr id="25" name="slide25" descr="Dashboard 13.1">
+            <a:extLst>
+              <a:ext uri="{FF2B5EF4-FFF2-40B4-BE49-F238E27FC236}">
+                <a16:creationId xmlns:a16="http://schemas.microsoft.com/office/drawing/2014/main" id="{838D13CE-DD0D-4C6F-B764-FCCAFBB7CDD5}"/>
               </a:ext>
             </a:extLst>
           </p:cNvPr>
@@ -3836,8 +3839,8 @@
         </p:blipFill>
         <p:spPr>
           <a:xfrm>
-            <a:off x="880355" y="0"/>
-            <a:ext cx="10431289" cy="6858000"/>
+            <a:off x="986450" y="0"/>
+            <a:ext cx="10219099" cy="6858000"/>
           </a:xfrm>
           <a:prstGeom prst="rect">
             <a:avLst/>
@@ -3847,7 +3850,7 @@
     </p:spTree>
     <p:extLst>
       <p:ext uri="{BB962C8B-B14F-4D97-AF65-F5344CB8AC3E}">
-        <p14:creationId xmlns:p14="http://schemas.microsoft.com/office/powerpoint/2010/main" val="95992585"/>
+        <p14:creationId xmlns:p14="http://schemas.microsoft.com/office/powerpoint/2010/main" val="602470699"/>
       </p:ext>
     </p:extLst>
   </p:cSld>
@@ -3876,10 +3879,10 @@
       </p:grpSpPr>
       <p:pic>
         <p:nvPicPr>
-          <p:cNvPr id="18" name="slide18" descr="Dashboard 17">
-            <a:extLst>
-              <a:ext uri="{FF2B5EF4-FFF2-40B4-BE49-F238E27FC236}">
-                <a16:creationId xmlns:a16="http://schemas.microsoft.com/office/drawing/2014/main" id="{20F19409-F2BF-4766-9302-B424131E7441}"/>
+          <p:cNvPr id="15" name="slide15" descr="Dashboard 14">
+            <a:extLst>
+              <a:ext uri="{FF2B5EF4-FFF2-40B4-BE49-F238E27FC236}">
+                <a16:creationId xmlns:a16="http://schemas.microsoft.com/office/drawing/2014/main" id="{4E31FD77-3785-4417-AD48-A8CD3487783D}"/>
               </a:ext>
             </a:extLst>
           </p:cNvPr>
@@ -3902,8 +3905,8 @@
         </p:blipFill>
         <p:spPr>
           <a:xfrm>
-            <a:off x="880355" y="0"/>
-            <a:ext cx="10431289" cy="6858000"/>
+            <a:off x="986450" y="0"/>
+            <a:ext cx="10219099" cy="6858000"/>
           </a:xfrm>
           <a:prstGeom prst="rect">
             <a:avLst/>
@@ -3942,10 +3945,10 @@
       </p:grpSpPr>
       <p:pic>
         <p:nvPicPr>
-          <p:cNvPr id="19" name="slide19" descr="Dashboard 18">
-            <a:extLst>
-              <a:ext uri="{FF2B5EF4-FFF2-40B4-BE49-F238E27FC236}">
-                <a16:creationId xmlns:a16="http://schemas.microsoft.com/office/drawing/2014/main" id="{C8BF9BA8-C266-4B5E-AAA2-9AA512E3BAA9}"/>
+          <p:cNvPr id="16" name="slide16" descr="Dashboard 15">
+            <a:extLst>
+              <a:ext uri="{FF2B5EF4-FFF2-40B4-BE49-F238E27FC236}">
+                <a16:creationId xmlns:a16="http://schemas.microsoft.com/office/drawing/2014/main" id="{5E604F81-9D5C-4115-901A-5503E30CA635}"/>
               </a:ext>
             </a:extLst>
           </p:cNvPr>
@@ -3968,8 +3971,8 @@
         </p:blipFill>
         <p:spPr>
           <a:xfrm>
-            <a:off x="880355" y="0"/>
-            <a:ext cx="10431289" cy="6858000"/>
+            <a:off x="986450" y="0"/>
+            <a:ext cx="10219099" cy="6858000"/>
           </a:xfrm>
           <a:prstGeom prst="rect">
             <a:avLst/>
@@ -4008,10 +4011,10 @@
       </p:grpSpPr>
       <p:pic>
         <p:nvPicPr>
-          <p:cNvPr id="20" name="slide20" descr="Dashboard 19">
-            <a:extLst>
-              <a:ext uri="{FF2B5EF4-FFF2-40B4-BE49-F238E27FC236}">
-                <a16:creationId xmlns:a16="http://schemas.microsoft.com/office/drawing/2014/main" id="{CF072144-10A6-4F00-A190-D5524C76ADBE}"/>
+          <p:cNvPr id="17" name="slide17" descr="Dashboard 16">
+            <a:extLst>
+              <a:ext uri="{FF2B5EF4-FFF2-40B4-BE49-F238E27FC236}">
+                <a16:creationId xmlns:a16="http://schemas.microsoft.com/office/drawing/2014/main" id="{C902D434-B729-405A-9BD3-CCC8F4326B7E}"/>
               </a:ext>
             </a:extLst>
           </p:cNvPr>
@@ -4034,8 +4037,8 @@
         </p:blipFill>
         <p:spPr>
           <a:xfrm>
-            <a:off x="880355" y="0"/>
-            <a:ext cx="10431289" cy="6858000"/>
+            <a:off x="986450" y="0"/>
+            <a:ext cx="10219099" cy="6858000"/>
           </a:xfrm>
           <a:prstGeom prst="rect">
             <a:avLst/>
@@ -4077,7 +4080,7 @@
           <p:cNvPr id="3" name="slide3" descr="Dashboard 2">
             <a:extLst>
               <a:ext uri="{FF2B5EF4-FFF2-40B4-BE49-F238E27FC236}">
-                <a16:creationId xmlns:a16="http://schemas.microsoft.com/office/drawing/2014/main" id="{B8A80030-3A2D-4E8B-A6FB-A3C5AD322F64}"/>
+                <a16:creationId xmlns:a16="http://schemas.microsoft.com/office/drawing/2014/main" id="{1215F4C9-7D91-4F2E-B260-8B22202C1249}"/>
               </a:ext>
             </a:extLst>
           </p:cNvPr>
@@ -4100,8 +4103,8 @@
         </p:blipFill>
         <p:spPr>
           <a:xfrm>
-            <a:off x="164663" y="0"/>
-            <a:ext cx="11862674" cy="6858000"/>
+            <a:off x="986450" y="0"/>
+            <a:ext cx="10219099" cy="6858000"/>
           </a:xfrm>
           <a:prstGeom prst="rect">
             <a:avLst/>
@@ -4111,7 +4114,7 @@
     </p:spTree>
     <p:extLst>
       <p:ext uri="{BB962C8B-B14F-4D97-AF65-F5344CB8AC3E}">
-        <p14:creationId xmlns:p14="http://schemas.microsoft.com/office/powerpoint/2010/main" val="3457313132"/>
+        <p14:creationId xmlns:p14="http://schemas.microsoft.com/office/powerpoint/2010/main" val="95992585"/>
       </p:ext>
     </p:extLst>
   </p:cSld>
@@ -4140,10 +4143,10 @@
       </p:grpSpPr>
       <p:pic>
         <p:nvPicPr>
-          <p:cNvPr id="21" name="slide21" descr="Dashboard 20">
-            <a:extLst>
-              <a:ext uri="{FF2B5EF4-FFF2-40B4-BE49-F238E27FC236}">
-                <a16:creationId xmlns:a16="http://schemas.microsoft.com/office/drawing/2014/main" id="{8BE2EB99-7BA0-4084-91BD-08AA8CCCC90D}"/>
+          <p:cNvPr id="18" name="slide18" descr="Dashboard 17">
+            <a:extLst>
+              <a:ext uri="{FF2B5EF4-FFF2-40B4-BE49-F238E27FC236}">
+                <a16:creationId xmlns:a16="http://schemas.microsoft.com/office/drawing/2014/main" id="{7CC8C508-A3D3-4A92-B854-ACEC6FF18D1C}"/>
               </a:ext>
             </a:extLst>
           </p:cNvPr>
@@ -4166,8 +4169,8 @@
         </p:blipFill>
         <p:spPr>
           <a:xfrm>
-            <a:off x="880355" y="0"/>
-            <a:ext cx="10431289" cy="6858000"/>
+            <a:off x="986450" y="0"/>
+            <a:ext cx="10219099" cy="6858000"/>
           </a:xfrm>
           <a:prstGeom prst="rect">
             <a:avLst/>
@@ -4206,10 +4209,10 @@
       </p:grpSpPr>
       <p:pic>
         <p:nvPicPr>
-          <p:cNvPr id="22" name="slide22" descr="Dashboard 21">
-            <a:extLst>
-              <a:ext uri="{FF2B5EF4-FFF2-40B4-BE49-F238E27FC236}">
-                <a16:creationId xmlns:a16="http://schemas.microsoft.com/office/drawing/2014/main" id="{EC2A145C-C816-493D-9A8F-CFFB8AB0CEB8}"/>
+          <p:cNvPr id="19" name="slide19" descr="Dashboard 18">
+            <a:extLst>
+              <a:ext uri="{FF2B5EF4-FFF2-40B4-BE49-F238E27FC236}">
+                <a16:creationId xmlns:a16="http://schemas.microsoft.com/office/drawing/2014/main" id="{99979355-0CC4-438C-8128-E31529961FB0}"/>
               </a:ext>
             </a:extLst>
           </p:cNvPr>
@@ -4232,8 +4235,206 @@
         </p:blipFill>
         <p:spPr>
           <a:xfrm>
-            <a:off x="880355" y="0"/>
-            <a:ext cx="10431289" cy="6858000"/>
+            <a:off x="986450" y="0"/>
+            <a:ext cx="10219099" cy="6858000"/>
+          </a:xfrm>
+          <a:prstGeom prst="rect">
+            <a:avLst/>
+          </a:prstGeom>
+        </p:spPr>
+      </p:pic>
+    </p:spTree>
+    <p:extLst>
+      <p:ext uri="{BB962C8B-B14F-4D97-AF65-F5344CB8AC3E}">
+        <p14:creationId xmlns:p14="http://schemas.microsoft.com/office/powerpoint/2010/main" val="95992585"/>
+      </p:ext>
+    </p:extLst>
+  </p:cSld>
+  <p:clrMapOvr>
+    <a:masterClrMapping/>
+  </p:clrMapOvr>
+</p:sld>
+</file>
+
+<file path=ppt/slides/slide22.xml><?xml version="1.0" encoding="utf-8"?>
+<p:sld xmlns:a="http://schemas.openxmlformats.org/drawingml/2006/main" xmlns:r="http://schemas.openxmlformats.org/officeDocument/2006/relationships" xmlns:p="http://schemas.openxmlformats.org/presentationml/2006/main">
+  <p:cSld>
+    <p:spTree>
+      <p:nvGrpSpPr>
+        <p:cNvPr id="1" name=""/>
+        <p:cNvGrpSpPr/>
+        <p:nvPr/>
+      </p:nvGrpSpPr>
+      <p:grpSpPr>
+        <a:xfrm>
+          <a:off x="0" y="0"/>
+          <a:ext cx="0" cy="0"/>
+          <a:chOff x="0" y="0"/>
+          <a:chExt cx="0" cy="0"/>
+        </a:xfrm>
+      </p:grpSpPr>
+      <p:pic>
+        <p:nvPicPr>
+          <p:cNvPr id="20" name="slide20" descr="Dashboard 19">
+            <a:extLst>
+              <a:ext uri="{FF2B5EF4-FFF2-40B4-BE49-F238E27FC236}">
+                <a16:creationId xmlns:a16="http://schemas.microsoft.com/office/drawing/2014/main" id="{6758ADEF-7140-4009-9E5D-43CEBBB06AFB}"/>
+              </a:ext>
+            </a:extLst>
+          </p:cNvPr>
+          <p:cNvPicPr>
+            <a:picLocks noChangeAspect="1"/>
+          </p:cNvPicPr>
+          <p:nvPr/>
+        </p:nvPicPr>
+        <p:blipFill>
+          <a:blip r:embed="rId2">
+            <a:extLst>
+              <a:ext uri="{28A0092B-C50C-407E-A947-70E740481C1C}">
+                <a14:useLocalDpi xmlns:a14="http://schemas.microsoft.com/office/drawing/2010/main" val="0"/>
+              </a:ext>
+            </a:extLst>
+          </a:blip>
+          <a:stretch>
+            <a:fillRect/>
+          </a:stretch>
+        </p:blipFill>
+        <p:spPr>
+          <a:xfrm>
+            <a:off x="986450" y="0"/>
+            <a:ext cx="10219099" cy="6858000"/>
+          </a:xfrm>
+          <a:prstGeom prst="rect">
+            <a:avLst/>
+          </a:prstGeom>
+        </p:spPr>
+      </p:pic>
+    </p:spTree>
+    <p:extLst>
+      <p:ext uri="{BB962C8B-B14F-4D97-AF65-F5344CB8AC3E}">
+        <p14:creationId xmlns:p14="http://schemas.microsoft.com/office/powerpoint/2010/main" val="95992585"/>
+      </p:ext>
+    </p:extLst>
+  </p:cSld>
+  <p:clrMapOvr>
+    <a:masterClrMapping/>
+  </p:clrMapOvr>
+</p:sld>
+</file>
+
+<file path=ppt/slides/slide23.xml><?xml version="1.0" encoding="utf-8"?>
+<p:sld xmlns:a="http://schemas.openxmlformats.org/drawingml/2006/main" xmlns:r="http://schemas.openxmlformats.org/officeDocument/2006/relationships" xmlns:p="http://schemas.openxmlformats.org/presentationml/2006/main">
+  <p:cSld>
+    <p:spTree>
+      <p:nvGrpSpPr>
+        <p:cNvPr id="1" name=""/>
+        <p:cNvGrpSpPr/>
+        <p:nvPr/>
+      </p:nvGrpSpPr>
+      <p:grpSpPr>
+        <a:xfrm>
+          <a:off x="0" y="0"/>
+          <a:ext cx="0" cy="0"/>
+          <a:chOff x="0" y="0"/>
+          <a:chExt cx="0" cy="0"/>
+        </a:xfrm>
+      </p:grpSpPr>
+      <p:pic>
+        <p:nvPicPr>
+          <p:cNvPr id="21" name="slide21" descr="Dashboard 20">
+            <a:extLst>
+              <a:ext uri="{FF2B5EF4-FFF2-40B4-BE49-F238E27FC236}">
+                <a16:creationId xmlns:a16="http://schemas.microsoft.com/office/drawing/2014/main" id="{CE2647FF-0770-459C-86AC-C06C37DB46CD}"/>
+              </a:ext>
+            </a:extLst>
+          </p:cNvPr>
+          <p:cNvPicPr>
+            <a:picLocks noChangeAspect="1"/>
+          </p:cNvPicPr>
+          <p:nvPr/>
+        </p:nvPicPr>
+        <p:blipFill>
+          <a:blip r:embed="rId2">
+            <a:extLst>
+              <a:ext uri="{28A0092B-C50C-407E-A947-70E740481C1C}">
+                <a14:useLocalDpi xmlns:a14="http://schemas.microsoft.com/office/drawing/2010/main" val="0"/>
+              </a:ext>
+            </a:extLst>
+          </a:blip>
+          <a:stretch>
+            <a:fillRect/>
+          </a:stretch>
+        </p:blipFill>
+        <p:spPr>
+          <a:xfrm>
+            <a:off x="986450" y="0"/>
+            <a:ext cx="10219099" cy="6858000"/>
+          </a:xfrm>
+          <a:prstGeom prst="rect">
+            <a:avLst/>
+          </a:prstGeom>
+        </p:spPr>
+      </p:pic>
+    </p:spTree>
+    <p:extLst>
+      <p:ext uri="{BB962C8B-B14F-4D97-AF65-F5344CB8AC3E}">
+        <p14:creationId xmlns:p14="http://schemas.microsoft.com/office/powerpoint/2010/main" val="95992585"/>
+      </p:ext>
+    </p:extLst>
+  </p:cSld>
+  <p:clrMapOvr>
+    <a:masterClrMapping/>
+  </p:clrMapOvr>
+</p:sld>
+</file>
+
+<file path=ppt/slides/slide24.xml><?xml version="1.0" encoding="utf-8"?>
+<p:sld xmlns:a="http://schemas.openxmlformats.org/drawingml/2006/main" xmlns:r="http://schemas.openxmlformats.org/officeDocument/2006/relationships" xmlns:p="http://schemas.openxmlformats.org/presentationml/2006/main">
+  <p:cSld>
+    <p:spTree>
+      <p:nvGrpSpPr>
+        <p:cNvPr id="1" name=""/>
+        <p:cNvGrpSpPr/>
+        <p:nvPr/>
+      </p:nvGrpSpPr>
+      <p:grpSpPr>
+        <a:xfrm>
+          <a:off x="0" y="0"/>
+          <a:ext cx="0" cy="0"/>
+          <a:chOff x="0" y="0"/>
+          <a:chExt cx="0" cy="0"/>
+        </a:xfrm>
+      </p:grpSpPr>
+      <p:pic>
+        <p:nvPicPr>
+          <p:cNvPr id="22" name="slide22" descr="Dashboard 21">
+            <a:extLst>
+              <a:ext uri="{FF2B5EF4-FFF2-40B4-BE49-F238E27FC236}">
+                <a16:creationId xmlns:a16="http://schemas.microsoft.com/office/drawing/2014/main" id="{4738C1CD-CD16-43C1-BC51-D9DCE5F6F356}"/>
+              </a:ext>
+            </a:extLst>
+          </p:cNvPr>
+          <p:cNvPicPr>
+            <a:picLocks noChangeAspect="1"/>
+          </p:cNvPicPr>
+          <p:nvPr/>
+        </p:nvPicPr>
+        <p:blipFill>
+          <a:blip r:embed="rId2">
+            <a:extLst>
+              <a:ext uri="{28A0092B-C50C-407E-A947-70E740481C1C}">
+                <a14:useLocalDpi xmlns:a14="http://schemas.microsoft.com/office/drawing/2010/main" val="0"/>
+              </a:ext>
+            </a:extLst>
+          </a:blip>
+          <a:stretch>
+            <a:fillRect/>
+          </a:stretch>
+        </p:blipFill>
+        <p:spPr>
+          <a:xfrm>
+            <a:off x="986450" y="0"/>
+            <a:ext cx="10219099" cy="6858000"/>
           </a:xfrm>
           <a:prstGeom prst="rect">
             <a:avLst/>
@@ -4275,7 +4476,7 @@
           <p:cNvPr id="4" name="slide4" descr="Dashboard 3">
             <a:extLst>
               <a:ext uri="{FF2B5EF4-FFF2-40B4-BE49-F238E27FC236}">
-                <a16:creationId xmlns:a16="http://schemas.microsoft.com/office/drawing/2014/main" id="{6CFD4F0A-FA99-4AB5-A18E-3D50766BD86C}"/>
+                <a16:creationId xmlns:a16="http://schemas.microsoft.com/office/drawing/2014/main" id="{17D612CE-0B67-4B50-A0C7-9F5E66076A6E}"/>
               </a:ext>
             </a:extLst>
           </p:cNvPr>
@@ -4298,8 +4499,8 @@
         </p:blipFill>
         <p:spPr>
           <a:xfrm>
-            <a:off x="880355" y="0"/>
-            <a:ext cx="10431289" cy="6858000"/>
+            <a:off x="986450" y="0"/>
+            <a:ext cx="10219099" cy="6858000"/>
           </a:xfrm>
           <a:prstGeom prst="rect">
             <a:avLst/>
@@ -4338,10 +4539,10 @@
       </p:grpSpPr>
       <p:pic>
         <p:nvPicPr>
-          <p:cNvPr id="5" name="slide5" descr="Dashboard 4">
-            <a:extLst>
-              <a:ext uri="{FF2B5EF4-FFF2-40B4-BE49-F238E27FC236}">
-                <a16:creationId xmlns:a16="http://schemas.microsoft.com/office/drawing/2014/main" id="{97438431-0027-4D52-9F67-A37D9CCAA50A}"/>
+          <p:cNvPr id="23" name="slide23" descr="Dashboard 3.1">
+            <a:extLst>
+              <a:ext uri="{FF2B5EF4-FFF2-40B4-BE49-F238E27FC236}">
+                <a16:creationId xmlns:a16="http://schemas.microsoft.com/office/drawing/2014/main" id="{495B6FE8-B667-4E39-AF9A-C0C91444A89B}"/>
               </a:ext>
             </a:extLst>
           </p:cNvPr>
@@ -4364,8 +4565,8 @@
         </p:blipFill>
         <p:spPr>
           <a:xfrm>
-            <a:off x="880355" y="0"/>
-            <a:ext cx="10431289" cy="6858000"/>
+            <a:off x="986450" y="0"/>
+            <a:ext cx="10219099" cy="6858000"/>
           </a:xfrm>
           <a:prstGeom prst="rect">
             <a:avLst/>
@@ -4375,7 +4576,7 @@
     </p:spTree>
     <p:extLst>
       <p:ext uri="{BB962C8B-B14F-4D97-AF65-F5344CB8AC3E}">
-        <p14:creationId xmlns:p14="http://schemas.microsoft.com/office/powerpoint/2010/main" val="95992585"/>
+        <p14:creationId xmlns:p14="http://schemas.microsoft.com/office/powerpoint/2010/main" val="2701990494"/>
       </p:ext>
     </p:extLst>
   </p:cSld>
@@ -4404,10 +4605,10 @@
       </p:grpSpPr>
       <p:pic>
         <p:nvPicPr>
-          <p:cNvPr id="6" name="slide6" descr="Dashboard 5">
-            <a:extLst>
-              <a:ext uri="{FF2B5EF4-FFF2-40B4-BE49-F238E27FC236}">
-                <a16:creationId xmlns:a16="http://schemas.microsoft.com/office/drawing/2014/main" id="{4D035467-6337-42D6-A08C-63AD89EAE539}"/>
+          <p:cNvPr id="24" name="slide24" descr="Dashboard 3.2">
+            <a:extLst>
+              <a:ext uri="{FF2B5EF4-FFF2-40B4-BE49-F238E27FC236}">
+                <a16:creationId xmlns:a16="http://schemas.microsoft.com/office/drawing/2014/main" id="{AAEFD998-B22D-4467-A1DA-3797EFB88411}"/>
               </a:ext>
             </a:extLst>
           </p:cNvPr>
@@ -4430,8 +4631,8 @@
         </p:blipFill>
         <p:spPr>
           <a:xfrm>
-            <a:off x="164663" y="0"/>
-            <a:ext cx="11862674" cy="6858000"/>
+            <a:off x="986450" y="0"/>
+            <a:ext cx="10219099" cy="6858000"/>
           </a:xfrm>
           <a:prstGeom prst="rect">
             <a:avLst/>
@@ -4441,7 +4642,7 @@
     </p:spTree>
     <p:extLst>
       <p:ext uri="{BB962C8B-B14F-4D97-AF65-F5344CB8AC3E}">
-        <p14:creationId xmlns:p14="http://schemas.microsoft.com/office/powerpoint/2010/main" val="1139881555"/>
+        <p14:creationId xmlns:p14="http://schemas.microsoft.com/office/powerpoint/2010/main" val="2373798760"/>
       </p:ext>
     </p:extLst>
   </p:cSld>
@@ -4470,10 +4671,10 @@
       </p:grpSpPr>
       <p:pic>
         <p:nvPicPr>
-          <p:cNvPr id="7" name="slide7" descr="Dashboard 6">
-            <a:extLst>
-              <a:ext uri="{FF2B5EF4-FFF2-40B4-BE49-F238E27FC236}">
-                <a16:creationId xmlns:a16="http://schemas.microsoft.com/office/drawing/2014/main" id="{4B2BC379-73E2-469C-B60C-DE8F1483138A}"/>
+          <p:cNvPr id="5" name="slide5" descr="Dashboard 4">
+            <a:extLst>
+              <a:ext uri="{FF2B5EF4-FFF2-40B4-BE49-F238E27FC236}">
+                <a16:creationId xmlns:a16="http://schemas.microsoft.com/office/drawing/2014/main" id="{CD58A0AA-1BC4-417B-88E8-1DC69549ACA4}"/>
               </a:ext>
             </a:extLst>
           </p:cNvPr>
@@ -4496,8 +4697,8 @@
         </p:blipFill>
         <p:spPr>
           <a:xfrm>
-            <a:off x="880355" y="0"/>
-            <a:ext cx="10431289" cy="6858000"/>
+            <a:off x="986450" y="0"/>
+            <a:ext cx="10219099" cy="6858000"/>
           </a:xfrm>
           <a:prstGeom prst="rect">
             <a:avLst/>
@@ -4536,10 +4737,10 @@
       </p:grpSpPr>
       <p:pic>
         <p:nvPicPr>
-          <p:cNvPr id="8" name="slide8" descr="Dashboard 7">
-            <a:extLst>
-              <a:ext uri="{FF2B5EF4-FFF2-40B4-BE49-F238E27FC236}">
-                <a16:creationId xmlns:a16="http://schemas.microsoft.com/office/drawing/2014/main" id="{FF292312-6021-4CC3-8A3B-04CD0440B8F6}"/>
+          <p:cNvPr id="6" name="slide6" descr="Dashboard 5">
+            <a:extLst>
+              <a:ext uri="{FF2B5EF4-FFF2-40B4-BE49-F238E27FC236}">
+                <a16:creationId xmlns:a16="http://schemas.microsoft.com/office/drawing/2014/main" id="{A8D7EC6D-E0CA-4A6F-B541-AEB02D028E09}"/>
               </a:ext>
             </a:extLst>
           </p:cNvPr>
@@ -4562,8 +4763,8 @@
         </p:blipFill>
         <p:spPr>
           <a:xfrm>
-            <a:off x="880355" y="0"/>
-            <a:ext cx="10431289" cy="6858000"/>
+            <a:off x="986450" y="0"/>
+            <a:ext cx="10219099" cy="6858000"/>
           </a:xfrm>
           <a:prstGeom prst="rect">
             <a:avLst/>
@@ -4602,10 +4803,10 @@
       </p:grpSpPr>
       <p:pic>
         <p:nvPicPr>
-          <p:cNvPr id="9" name="slide9" descr="Dashboard 8">
-            <a:extLst>
-              <a:ext uri="{FF2B5EF4-FFF2-40B4-BE49-F238E27FC236}">
-                <a16:creationId xmlns:a16="http://schemas.microsoft.com/office/drawing/2014/main" id="{6445F66E-53E3-4A02-8796-9F28492F4A9B}"/>
+          <p:cNvPr id="7" name="slide7" descr="Dashboard 6">
+            <a:extLst>
+              <a:ext uri="{FF2B5EF4-FFF2-40B4-BE49-F238E27FC236}">
+                <a16:creationId xmlns:a16="http://schemas.microsoft.com/office/drawing/2014/main" id="{860B515F-9D7D-44A4-9CD4-C8C16AB986B3}"/>
               </a:ext>
             </a:extLst>
           </p:cNvPr>
@@ -4628,8 +4829,8 @@
         </p:blipFill>
         <p:spPr>
           <a:xfrm>
-            <a:off x="880355" y="0"/>
-            <a:ext cx="10431289" cy="6858000"/>
+            <a:off x="986450" y="0"/>
+            <a:ext cx="10219099" cy="6858000"/>
           </a:xfrm>
           <a:prstGeom prst="rect">
             <a:avLst/>
@@ -4668,10 +4869,10 @@
       </p:grpSpPr>
       <p:pic>
         <p:nvPicPr>
-          <p:cNvPr id="10" name="slide10" descr="Dashboard 9">
-            <a:extLst>
-              <a:ext uri="{FF2B5EF4-FFF2-40B4-BE49-F238E27FC236}">
-                <a16:creationId xmlns:a16="http://schemas.microsoft.com/office/drawing/2014/main" id="{BE18DD41-2747-4280-BB67-CDD1DFB9B457}"/>
+          <p:cNvPr id="8" name="slide8" descr="Dashboard 7">
+            <a:extLst>
+              <a:ext uri="{FF2B5EF4-FFF2-40B4-BE49-F238E27FC236}">
+                <a16:creationId xmlns:a16="http://schemas.microsoft.com/office/drawing/2014/main" id="{7DAD40A1-19B7-4FE0-9B56-3198C7B3872B}"/>
               </a:ext>
             </a:extLst>
           </p:cNvPr>
@@ -4694,8 +4895,8 @@
         </p:blipFill>
         <p:spPr>
           <a:xfrm>
-            <a:off x="880355" y="0"/>
-            <a:ext cx="10431289" cy="6858000"/>
+            <a:off x="986450" y="0"/>
+            <a:ext cx="10219099" cy="6858000"/>
           </a:xfrm>
           <a:prstGeom prst="rect">
             <a:avLst/>

</xml_diff>